<commit_message>
Part 3: remove cost chips, shrink-order and internal notes; rename reserve; investor-facing wording on milestones page
Co-Authored-By: Claude Opus 5.5 <noreply@anthropic.com>
Claude-Session: https://claude.ai/code/session_01NTagjVHGZdXLvG9VCNzDRT
</commit_message>
<xml_diff>
--- a/slides/Vitonaut_part3_draft.pptx
+++ b/slides/Vitonaut_part3_draft.pptx
@@ -1160,7 +1160,7 @@
                 <a:ea typeface="微软雅黑"/>
                 <a:cs typeface="微软雅黑"/>
               </a:rPr>
-              <a:t>Source: 卓悦博士执行计划；王中杰博士算力测算；Vitonaut BP v13 §3.2</a:t>
+              <a:t>Source: Vitonaut 第一年执行计划</a:t>
             </a:r>
             <a:r>
               <a:rPr sz="1050">
@@ -1285,8 +1285,8 @@
         </p:nvSpPr>
         <p:spPr>
           <a:xfrm>
-            <a:off x="530352" y="1783080"/>
-            <a:ext cx="2576322" cy="2743200"/>
+            <a:off x="530352" y="1965960"/>
+            <a:ext cx="2576322" cy="3017520"/>
           </a:xfrm>
           <a:prstGeom prst="rect">
             <a:avLst/>
@@ -1314,7 +1314,7 @@
               <a:buNone/>
             </a:pPr>
             <a:r>
-              <a:rPr lang="zh-CN" altLang="en-US" sz="1000" b="1">
+              <a:rPr lang="zh-CN" altLang="en-US" sz="1100" b="1">
                 <a:solidFill>
                   <a:srgbClr val="08A6F6"/>
                 </a:solidFill>
@@ -1358,7 +1358,7 @@
               <a:buNone/>
             </a:pPr>
             <a:r>
-              <a:rPr lang="zh-CN" altLang="en-US" sz="1000" b="1">
+              <a:rPr lang="zh-CN" altLang="en-US" sz="1100" b="1">
                 <a:solidFill>
                   <a:srgbClr val="08A6F6"/>
                 </a:solidFill>
@@ -1369,7 +1369,7 @@
               <a:t>闸门  </a:t>
             </a:r>
             <a:r>
-              <a:rPr lang="zh-CN" altLang="en-US" sz="1250" b="1">
+              <a:rPr lang="zh-CN" altLang="en-US" sz="1350" b="1">
                 <a:solidFill>
                   <a:srgbClr val="061F32"/>
                 </a:solidFill>
@@ -1391,7 +1391,7 @@
               <a:buNone/>
             </a:pPr>
             <a:r>
-              <a:rPr lang="zh-CN" altLang="en-US" sz="1000" b="1">
+              <a:rPr lang="zh-CN" altLang="en-US" sz="1100" b="1">
                 <a:solidFill>
                   <a:srgbClr val="08A6F6"/>
                 </a:solidFill>
@@ -1413,7 +1413,7 @@
               <a:buNone/>
             </a:pPr>
             <a:r>
-              <a:rPr lang="zh-CN" altLang="en-US" sz="1250">
+              <a:rPr lang="zh-CN" altLang="en-US" sz="1350">
                 <a:solidFill>
                   <a:srgbClr val="061F32"/>
                 </a:solidFill>
@@ -1432,7 +1432,7 @@
               <a:buNone/>
             </a:pPr>
             <a:r>
-              <a:rPr lang="zh-CN" altLang="en-US" sz="1000" b="1">
+              <a:rPr lang="zh-CN" altLang="en-US" sz="1100" b="1">
                 <a:solidFill>
                   <a:srgbClr val="08A6F6"/>
                 </a:solidFill>
@@ -1443,7 +1443,7 @@
               <a:t>收入  </a:t>
             </a:r>
             <a:r>
-              <a:rPr lang="zh-CN" altLang="en-US" sz="1250" b="1">
+              <a:rPr lang="zh-CN" altLang="en-US" sz="1350" b="1">
                 <a:solidFill>
                   <a:srgbClr val="061F32"/>
                 </a:solidFill>
@@ -1464,7 +1464,7 @@
         </p:nvSpPr>
         <p:spPr>
           <a:xfrm>
-            <a:off x="3106674" y="2926080"/>
+            <a:off x="3106674" y="3200400"/>
             <a:ext cx="274320" cy="365760"/>
           </a:xfrm>
           <a:prstGeom prst="rect">
@@ -1506,8 +1506,8 @@
         </p:nvSpPr>
         <p:spPr>
           <a:xfrm>
-            <a:off x="3380994" y="1554480"/>
-            <a:ext cx="2576322" cy="2971800"/>
+            <a:off x="3380994" y="1691640"/>
+            <a:ext cx="2576322" cy="3291840"/>
           </a:xfrm>
           <a:prstGeom prst="rect">
             <a:avLst/>
@@ -1535,7 +1535,7 @@
               <a:buNone/>
             </a:pPr>
             <a:r>
-              <a:rPr lang="zh-CN" altLang="en-US" sz="1000" b="1">
+              <a:rPr lang="zh-CN" altLang="en-US" sz="1100" b="1">
                 <a:solidFill>
                   <a:srgbClr val="0B5AA8"/>
                 </a:solidFill>
@@ -1579,7 +1579,7 @@
               <a:buNone/>
             </a:pPr>
             <a:r>
-              <a:rPr lang="zh-CN" altLang="en-US" sz="1000" b="1">
+              <a:rPr lang="zh-CN" altLang="en-US" sz="1100" b="1">
                 <a:solidFill>
                   <a:srgbClr val="0B5AA8"/>
                 </a:solidFill>
@@ -1590,7 +1590,7 @@
               <a:t>闸门  </a:t>
             </a:r>
             <a:r>
-              <a:rPr lang="zh-CN" altLang="en-US" sz="1250" b="1">
+              <a:rPr lang="zh-CN" altLang="en-US" sz="1350" b="1">
                 <a:solidFill>
                   <a:srgbClr val="061F32"/>
                 </a:solidFill>
@@ -1598,7 +1598,7 @@
                 <a:ea typeface="微软雅黑"/>
                 <a:cs typeface="微软雅黑"/>
               </a:rPr>
-              <a:t>Level 2 回顾性 AUROC + 双轨迹首个结果</a:t>
+              <a:t>Level 2 预测准确度 + 双轨迹首个结果</a:t>
             </a:r>
           </a:p>
           <a:p>
@@ -1612,7 +1612,7 @@
               <a:buNone/>
             </a:pPr>
             <a:r>
-              <a:rPr lang="zh-CN" altLang="en-US" sz="1000" b="1">
+              <a:rPr lang="zh-CN" altLang="en-US" sz="1100" b="1">
                 <a:solidFill>
                   <a:srgbClr val="0B5AA8"/>
                 </a:solidFill>
@@ -1634,7 +1634,7 @@
               <a:buNone/>
             </a:pPr>
             <a:r>
-              <a:rPr lang="zh-CN" altLang="en-US" sz="1250">
+              <a:rPr lang="zh-CN" altLang="en-US" sz="1350">
                 <a:solidFill>
                   <a:srgbClr val="061F32"/>
                 </a:solidFill>
@@ -1653,7 +1653,7 @@
               <a:buNone/>
             </a:pPr>
             <a:r>
-              <a:rPr lang="zh-CN" altLang="en-US" sz="1000" b="1">
+              <a:rPr lang="zh-CN" altLang="en-US" sz="1100" b="1">
                 <a:solidFill>
                   <a:srgbClr val="0B5AA8"/>
                 </a:solidFill>
@@ -1664,7 +1664,7 @@
               <a:t>收入  </a:t>
             </a:r>
             <a:r>
-              <a:rPr lang="zh-CN" altLang="en-US" sz="1250" b="1">
+              <a:rPr lang="zh-CN" altLang="en-US" sz="1350" b="1">
                 <a:solidFill>
                   <a:srgbClr val="061F32"/>
                 </a:solidFill>
@@ -1685,7 +1685,7 @@
         </p:nvSpPr>
         <p:spPr>
           <a:xfrm>
-            <a:off x="5957316" y="2926080"/>
+            <a:off x="5957316" y="3200400"/>
             <a:ext cx="274320" cy="365760"/>
           </a:xfrm>
           <a:prstGeom prst="rect">
@@ -1727,8 +1727,8 @@
         </p:nvSpPr>
         <p:spPr>
           <a:xfrm>
-            <a:off x="6231636" y="1325880"/>
-            <a:ext cx="2576322" cy="3200400"/>
+            <a:off x="6231636" y="1417320"/>
+            <a:ext cx="2576322" cy="3566160"/>
           </a:xfrm>
           <a:prstGeom prst="rect">
             <a:avLst/>
@@ -1756,7 +1756,7 @@
               <a:buNone/>
             </a:pPr>
             <a:r>
-              <a:rPr lang="zh-CN" altLang="en-US" sz="1000" b="1">
+              <a:rPr lang="zh-CN" altLang="en-US" sz="1100" b="1">
                 <a:solidFill>
                   <a:srgbClr val="E3F4FE"/>
                 </a:solidFill>
@@ -1800,7 +1800,7 @@
               <a:buNone/>
             </a:pPr>
             <a:r>
-              <a:rPr lang="zh-CN" altLang="en-US" sz="1000" b="1">
+              <a:rPr lang="zh-CN" altLang="en-US" sz="1100" b="1">
                 <a:solidFill>
                   <a:srgbClr val="E3F4FE"/>
                 </a:solidFill>
@@ -1811,7 +1811,7 @@
               <a:t>证据  </a:t>
             </a:r>
             <a:r>
-              <a:rPr lang="zh-CN" altLang="en-US" sz="1250" b="1">
+              <a:rPr lang="zh-CN" altLang="en-US" sz="1350" b="1">
                 <a:solidFill>
                   <a:srgbClr val="FFFFFF"/>
                 </a:solidFill>
@@ -1833,7 +1833,7 @@
               <a:buNone/>
             </a:pPr>
             <a:r>
-              <a:rPr lang="zh-CN" altLang="en-US" sz="1000" b="1">
+              <a:rPr lang="zh-CN" altLang="en-US" sz="1100" b="1">
                 <a:solidFill>
                   <a:srgbClr val="E3F4FE"/>
                 </a:solidFill>
@@ -1855,7 +1855,7 @@
               <a:buNone/>
             </a:pPr>
             <a:r>
-              <a:rPr lang="zh-CN" altLang="en-US" sz="1250">
+              <a:rPr lang="zh-CN" altLang="en-US" sz="1350">
                 <a:solidFill>
                   <a:srgbClr val="FFFFFF"/>
                 </a:solidFill>
@@ -1874,7 +1874,7 @@
               <a:buNone/>
             </a:pPr>
             <a:r>
-              <a:rPr lang="zh-CN" altLang="en-US" sz="1000" b="1">
+              <a:rPr lang="zh-CN" altLang="en-US" sz="1100" b="1">
                 <a:solidFill>
                   <a:srgbClr val="E3F4FE"/>
                 </a:solidFill>
@@ -1885,7 +1885,7 @@
               <a:t>收入  </a:t>
             </a:r>
             <a:r>
-              <a:rPr lang="zh-CN" altLang="en-US" sz="1250" b="1">
+              <a:rPr lang="zh-CN" altLang="en-US" sz="1350" b="1">
                 <a:solidFill>
                   <a:srgbClr val="FFFFFF"/>
                 </a:solidFill>
@@ -1906,7 +1906,7 @@
         </p:nvSpPr>
         <p:spPr>
           <a:xfrm>
-            <a:off x="8807958" y="2926080"/>
+            <a:off x="8807958" y="3200400"/>
             <a:ext cx="274320" cy="365760"/>
           </a:xfrm>
           <a:prstGeom prst="rect">
@@ -1948,8 +1948,8 @@
         </p:nvSpPr>
         <p:spPr>
           <a:xfrm>
-            <a:off x="9082278" y="1097280"/>
-            <a:ext cx="2576322" cy="3429000"/>
+            <a:off x="9082278" y="1143000"/>
+            <a:ext cx="2576322" cy="3840480"/>
           </a:xfrm>
           <a:prstGeom prst="rect">
             <a:avLst/>
@@ -1977,7 +1977,7 @@
               <a:buNone/>
             </a:pPr>
             <a:r>
-              <a:rPr lang="zh-CN" altLang="en-US" sz="1000" b="1">
+              <a:rPr lang="zh-CN" altLang="en-US" sz="1100" b="1">
                 <a:solidFill>
                   <a:srgbClr val="99BDED"/>
                 </a:solidFill>
@@ -2021,7 +2021,7 @@
               <a:buNone/>
             </a:pPr>
             <a:r>
-              <a:rPr lang="zh-CN" altLang="en-US" sz="1000" b="1">
+              <a:rPr lang="zh-CN" altLang="en-US" sz="1100" b="1">
                 <a:solidFill>
                   <a:srgbClr val="99BDED"/>
                 </a:solidFill>
@@ -2032,7 +2032,7 @@
               <a:t>证据  </a:t>
             </a:r>
             <a:r>
-              <a:rPr lang="zh-CN" altLang="en-US" sz="1250" b="1">
+              <a:rPr lang="zh-CN" altLang="en-US" sz="1350" b="1">
                 <a:solidFill>
                   <a:srgbClr val="FFFFFF"/>
                 </a:solidFill>
@@ -2054,7 +2054,7 @@
               <a:buNone/>
             </a:pPr>
             <a:r>
-              <a:rPr lang="zh-CN" altLang="en-US" sz="1000" b="1">
+              <a:rPr lang="zh-CN" altLang="en-US" sz="1100" b="1">
                 <a:solidFill>
                   <a:srgbClr val="99BDED"/>
                 </a:solidFill>
@@ -2076,7 +2076,7 @@
               <a:buNone/>
             </a:pPr>
             <a:r>
-              <a:rPr lang="zh-CN" altLang="en-US" sz="1250">
+              <a:rPr lang="zh-CN" altLang="en-US" sz="1350">
                 <a:solidFill>
                   <a:srgbClr val="FFFFFF"/>
                 </a:solidFill>
@@ -2095,7 +2095,7 @@
               <a:buNone/>
             </a:pPr>
             <a:r>
-              <a:rPr lang="zh-CN" altLang="en-US" sz="1000" b="1">
+              <a:rPr lang="zh-CN" altLang="en-US" sz="1100" b="1">
                 <a:solidFill>
                   <a:srgbClr val="99BDED"/>
                 </a:solidFill>
@@ -2106,7 +2106,7 @@
               <a:t>收入  </a:t>
             </a:r>
             <a:r>
-              <a:rPr lang="zh-CN" altLang="en-US" sz="1250" b="1">
+              <a:rPr lang="zh-CN" altLang="en-US" sz="1350" b="1">
                 <a:solidFill>
                   <a:srgbClr val="FFFFFF"/>
                 </a:solidFill>
@@ -2121,20 +2121,62 @@
       </p:sp>
       <p:sp>
         <p:nvSpPr>
-          <p:cNvPr id="908" name="要点条 1"/>
+          <p:cNvPr id="917" name="品牌页脚"/>
+          <p:cNvSpPr txBox="1"/>
+          <p:nvPr/>
+        </p:nvSpPr>
+        <p:spPr>
+          <a:xfrm>
+            <a:off x="530352" y="6382512"/>
+            <a:ext cx="7315200" cy="164592"/>
+          </a:xfrm>
+          <a:prstGeom prst="rect">
+            <a:avLst/>
+          </a:prstGeom>
+          <a:noFill/>
+        </p:spPr>
+        <p:txBody>
+          <a:bodyPr wrap="square" lIns="0" tIns="0" rIns="0" bIns="0" anchor="t">
+            <a:noAutofit/>
+          </a:bodyPr>
+          <a:lstStyle/>
+          <a:p>
+            <a:pPr algn="l">
+              <a:lnSpc>
+                <a:spcPct val="110000"/>
+              </a:lnSpc>
+              <a:buNone/>
+            </a:pPr>
+            <a:r>
+              <a:rPr lang="zh-CN" altLang="en-US" sz="1050">
+                <a:solidFill>
+                  <a:srgbClr val="808080"/>
+                </a:solidFill>
+                <a:latin typeface="微软雅黑"/>
+                <a:ea typeface="微软雅黑"/>
+                <a:cs typeface="微软雅黑"/>
+              </a:rPr>
+              <a:t>Vitonaut 维探 · AIVC 虚拟类器官 · 融资商业计划书</a:t>
+            </a:r>
+          </a:p>
+        </p:txBody>
+      </p:sp>
+      <p:sp>
+        <p:nvSpPr>
+          <p:cNvPr id="901" name="飞轮带"/>
           <p:cNvSpPr/>
           <p:nvPr/>
         </p:nvSpPr>
         <p:spPr>
           <a:xfrm>
-            <a:off x="530352" y="4800600"/>
-            <a:ext cx="54864" cy="1097280"/>
+            <a:off x="530352" y="5193792"/>
+            <a:ext cx="11128248" cy="749808"/>
           </a:xfrm>
           <a:prstGeom prst="rect">
             <a:avLst/>
           </a:prstGeom>
           <a:solidFill>
-            <a:srgbClr val="08A6F6"/>
+            <a:srgbClr val="061F32"/>
           </a:solidFill>
           <a:ln>
             <a:noFill/>
@@ -2150,14 +2192,14 @@
       </p:sp>
       <p:sp>
         <p:nvSpPr>
-          <p:cNvPr id="909" name="要点数字 1"/>
+          <p:cNvPr id="902" name="飞轮标签"/>
           <p:cNvSpPr txBox="1"/>
           <p:nvPr/>
         </p:nvSpPr>
         <p:spPr>
           <a:xfrm>
-            <a:off x="758952" y="4800600"/>
-            <a:ext cx="3252216" cy="548640"/>
+            <a:off x="777240" y="5193792"/>
+            <a:ext cx="2011680" cy="749808"/>
           </a:xfrm>
           <a:prstGeom prst="rect">
             <a:avLst/>
@@ -2177,100 +2219,29 @@
               <a:buNone/>
             </a:pPr>
             <a:r>
-              <a:rPr lang="zh-CN" altLang="en-US" sz="2800" b="1">
-                <a:solidFill>
-                  <a:srgbClr val="061F32"/>
-                </a:solidFill>
-                <a:latin typeface="微软雅黑"/>
-                <a:ea typeface="微软雅黑"/>
-                <a:cs typeface="微软雅黑"/>
-              </a:rPr>
-              <a:t>2.9 万元</a:t>
-            </a:r>
-          </a:p>
-        </p:txBody>
-      </p:sp>
-      <p:sp>
-        <p:nvSpPr>
-          <p:cNvPr id="910" name="要点说明 1"/>
+              <a:rPr lang="zh-CN" altLang="en-US" sz="2000" b="1">
+                <a:solidFill>
+                  <a:srgbClr val="FFFFFF"/>
+                </a:solidFill>
+                <a:latin typeface="微软雅黑"/>
+                <a:ea typeface="微软雅黑"/>
+                <a:cs typeface="微软雅黑"/>
+              </a:rPr>
+              <a:t>飞轮复利</a:t>
+            </a:r>
+          </a:p>
+        </p:txBody>
+      </p:sp>
+      <p:sp>
+        <p:nvSpPr>
+          <p:cNvPr id="903" name="飞轮说明"/>
           <p:cNvSpPr txBox="1"/>
           <p:nvPr/>
         </p:nvSpPr>
         <p:spPr>
           <a:xfrm>
-            <a:off x="758952" y="5376672"/>
-            <a:ext cx="3252216" cy="502920"/>
-          </a:xfrm>
-          <a:prstGeom prst="rect">
-            <a:avLst/>
-          </a:prstGeom>
-          <a:noFill/>
-        </p:spPr>
-        <p:txBody>
-          <a:bodyPr wrap="square" lIns="0" tIns="0" rIns="0" bIns="0" anchor="t">
-            <a:noAutofit/>
-          </a:bodyPr>
-          <a:lstStyle/>
-          <a:p>
-            <a:pPr algn="l">
-              <a:lnSpc>
-                <a:spcPct val="110000"/>
-              </a:lnSpc>
-              <a:buNone/>
-            </a:pPr>
-            <a:r>
-              <a:rPr lang="zh-CN" altLang="en-US" sz="1150">
-                <a:solidFill>
-                  <a:srgbClr val="44546A"/>
-                </a:solidFill>
-                <a:latin typeface="微软雅黑"/>
-                <a:ea typeface="微软雅黑"/>
-                <a:cs typeface="微软雅黑"/>
-              </a:rPr>
-              <a:t>每例湿实验直接成本</a:t>
-            </a:r>
-          </a:p>
-        </p:txBody>
-      </p:sp>
-      <p:sp>
-        <p:nvSpPr>
-          <p:cNvPr id="911" name="要点条 2"/>
-          <p:cNvSpPr/>
-          <p:nvPr/>
-        </p:nvSpPr>
-        <p:spPr>
-          <a:xfrm>
-            <a:off x="4331208" y="4800600"/>
-            <a:ext cx="54864" cy="1097280"/>
-          </a:xfrm>
-          <a:prstGeom prst="rect">
-            <a:avLst/>
-          </a:prstGeom>
-          <a:solidFill>
-            <a:srgbClr val="08A6F6"/>
-          </a:solidFill>
-          <a:ln>
-            <a:noFill/>
-          </a:ln>
-        </p:spPr>
-        <p:txBody>
-          <a:bodyPr wrap="square" lIns="109728" tIns="109728" rIns="109728" bIns="109728" anchor="ctr">
-            <a:noAutofit/>
-          </a:bodyPr>
-          <a:lstStyle/>
-          <a:p/>
-        </p:txBody>
-      </p:sp>
-      <p:sp>
-        <p:nvSpPr>
-          <p:cNvPr id="912" name="要点数字 2"/>
-          <p:cNvSpPr txBox="1"/>
-          <p:nvPr/>
-        </p:nvSpPr>
-        <p:spPr>
-          <a:xfrm>
-            <a:off x="4559808" y="4800600"/>
-            <a:ext cx="3252216" cy="548640"/>
+            <a:off x="2834640" y="5193792"/>
+            <a:ext cx="8595360" cy="749808"/>
           </a:xfrm>
           <a:prstGeom prst="rect">
             <a:avLst/>
@@ -2285,217 +2256,64 @@
           <a:p>
             <a:pPr algn="l">
               <a:lnSpc>
-                <a:spcPct val="110000"/>
-              </a:lnSpc>
-              <a:buNone/>
-            </a:pPr>
-            <a:r>
-              <a:rPr lang="zh-CN" altLang="en-US" sz="2800" b="1">
-                <a:solidFill>
-                  <a:srgbClr val="061F32"/>
-                </a:solidFill>
-                <a:latin typeface="微软雅黑"/>
-                <a:ea typeface="微软雅黑"/>
-                <a:cs typeface="微软雅黑"/>
-              </a:rPr>
-              <a:t>600 → 120 元</a:t>
-            </a:r>
-          </a:p>
-        </p:txBody>
-      </p:sp>
-      <p:sp>
-        <p:nvSpPr>
-          <p:cNvPr id="913" name="要点说明 2"/>
-          <p:cNvSpPr txBox="1"/>
-          <p:nvPr/>
-        </p:nvSpPr>
-        <p:spPr>
-          <a:xfrm>
-            <a:off x="4559808" y="5376672"/>
-            <a:ext cx="3252216" cy="502920"/>
-          </a:xfrm>
-          <a:prstGeom prst="rect">
-            <a:avLst/>
-          </a:prstGeom>
-          <a:noFill/>
-        </p:spPr>
-        <p:txBody>
-          <a:bodyPr wrap="square" lIns="0" tIns="0" rIns="0" bIns="0" anchor="t">
-            <a:noAutofit/>
-          </a:bodyPr>
-          <a:lstStyle/>
-          <a:p>
-            <a:pPr algn="l">
-              <a:lnSpc>
-                <a:spcPct val="110000"/>
-              </a:lnSpc>
-              <a:buNone/>
-            </a:pPr>
-            <a:r>
-              <a:rPr lang="zh-CN" altLang="en-US" sz="1150">
-                <a:solidFill>
-                  <a:srgbClr val="44546A"/>
-                </a:solidFill>
-                <a:latin typeface="微软雅黑"/>
-                <a:ea typeface="微软雅黑"/>
-                <a:cs typeface="微软雅黑"/>
-              </a:rPr>
-              <a:t>每样本算力成本（100 → 5 万样本）</a:t>
-            </a:r>
-          </a:p>
-        </p:txBody>
-      </p:sp>
-      <p:sp>
-        <p:nvSpPr>
-          <p:cNvPr id="914" name="要点条 3"/>
-          <p:cNvSpPr/>
-          <p:nvPr/>
-        </p:nvSpPr>
-        <p:spPr>
-          <a:xfrm>
-            <a:off x="8132064" y="4800600"/>
-            <a:ext cx="54864" cy="1097280"/>
-          </a:xfrm>
-          <a:prstGeom prst="rect">
-            <a:avLst/>
-          </a:prstGeom>
-          <a:solidFill>
-            <a:srgbClr val="08A6F6"/>
-          </a:solidFill>
-          <a:ln>
-            <a:noFill/>
-          </a:ln>
-        </p:spPr>
-        <p:txBody>
-          <a:bodyPr wrap="square" lIns="109728" tIns="109728" rIns="109728" bIns="109728" anchor="ctr">
-            <a:noAutofit/>
-          </a:bodyPr>
-          <a:lstStyle/>
-          <a:p/>
-        </p:txBody>
-      </p:sp>
-      <p:sp>
-        <p:nvSpPr>
-          <p:cNvPr id="915" name="要点数字 3"/>
-          <p:cNvSpPr txBox="1"/>
-          <p:nvPr/>
-        </p:nvSpPr>
-        <p:spPr>
-          <a:xfrm>
-            <a:off x="8360664" y="4800600"/>
-            <a:ext cx="3252216" cy="548640"/>
-          </a:xfrm>
-          <a:prstGeom prst="rect">
-            <a:avLst/>
-          </a:prstGeom>
-          <a:noFill/>
-        </p:spPr>
-        <p:txBody>
-          <a:bodyPr wrap="square" lIns="0" tIns="0" rIns="0" bIns="0" anchor="ctr">
-            <a:noAutofit/>
-          </a:bodyPr>
-          <a:lstStyle/>
-          <a:p>
-            <a:pPr algn="l">
-              <a:lnSpc>
-                <a:spcPct val="110000"/>
-              </a:lnSpc>
-              <a:buNone/>
-            </a:pPr>
-            <a:r>
-              <a:rPr lang="zh-CN" altLang="en-US" sz="2800" b="1">
-                <a:solidFill>
-                  <a:srgbClr val="061F32"/>
-                </a:solidFill>
-                <a:latin typeface="微软雅黑"/>
-                <a:ea typeface="微软雅黑"/>
-                <a:cs typeface="微软雅黑"/>
-              </a:rPr>
-              <a:t>飞轮复利</a:t>
-            </a:r>
-          </a:p>
-        </p:txBody>
-      </p:sp>
-      <p:sp>
-        <p:nvSpPr>
-          <p:cNvPr id="916" name="要点说明 3"/>
-          <p:cNvSpPr txBox="1"/>
-          <p:nvPr/>
-        </p:nvSpPr>
-        <p:spPr>
-          <a:xfrm>
-            <a:off x="8360664" y="5376672"/>
-            <a:ext cx="3252216" cy="502920"/>
-          </a:xfrm>
-          <a:prstGeom prst="rect">
-            <a:avLst/>
-          </a:prstGeom>
-          <a:noFill/>
-        </p:spPr>
-        <p:txBody>
-          <a:bodyPr wrap="square" lIns="0" tIns="0" rIns="0" bIns="0" anchor="t">
-            <a:noAutofit/>
-          </a:bodyPr>
-          <a:lstStyle/>
-          <a:p>
-            <a:pPr algn="l">
-              <a:lnSpc>
-                <a:spcPct val="110000"/>
-              </a:lnSpc>
-              <a:buNone/>
-            </a:pPr>
-            <a:r>
-              <a:rPr lang="zh-CN" altLang="en-US" sz="1150">
-                <a:solidFill>
-                  <a:srgbClr val="44546A"/>
-                </a:solidFill>
-                <a:latin typeface="微软雅黑"/>
-                <a:ea typeface="微软雅黑"/>
-                <a:cs typeface="微软雅黑"/>
-              </a:rPr>
-              <a:t>每个付费项目都沉淀配对数据：越用越准，越做越省</a:t>
-            </a:r>
-          </a:p>
-        </p:txBody>
-      </p:sp>
-      <p:sp>
-        <p:nvSpPr>
-          <p:cNvPr id="917" name="品牌页脚"/>
-          <p:cNvSpPr txBox="1"/>
-          <p:nvPr/>
-        </p:nvSpPr>
-        <p:spPr>
-          <a:xfrm>
-            <a:off x="530352" y="6382512"/>
-            <a:ext cx="7315200" cy="164592"/>
-          </a:xfrm>
-          <a:prstGeom prst="rect">
-            <a:avLst/>
-          </a:prstGeom>
-          <a:noFill/>
-        </p:spPr>
-        <p:txBody>
-          <a:bodyPr wrap="square" lIns="0" tIns="0" rIns="0" bIns="0" anchor="t">
-            <a:noAutofit/>
-          </a:bodyPr>
-          <a:lstStyle/>
-          <a:p>
-            <a:pPr algn="l">
-              <a:lnSpc>
-                <a:spcPct val="110000"/>
-              </a:lnSpc>
-              <a:buNone/>
-            </a:pPr>
-            <a:r>
-              <a:rPr lang="zh-CN" altLang="en-US" sz="1050">
-                <a:solidFill>
-                  <a:srgbClr val="808080"/>
-                </a:solidFill>
-                <a:latin typeface="微软雅黑"/>
-                <a:ea typeface="微软雅黑"/>
-                <a:cs typeface="微软雅黑"/>
-              </a:rPr>
-              <a:t>Vitonaut 维探 · AIVC 虚拟类器官 · 融资商业计划书</a:t>
+                <a:spcPct val="105000"/>
+              </a:lnSpc>
+              <a:buNone/>
+            </a:pPr>
+            <a:r>
+              <a:rPr lang="zh-CN" altLang="en-US" sz="1500" b="1">
+                <a:solidFill>
+                  <a:srgbClr val="FFFFFF"/>
+                </a:solidFill>
+                <a:latin typeface="微软雅黑"/>
+                <a:ea typeface="微软雅黑"/>
+                <a:cs typeface="微软雅黑"/>
+              </a:rPr>
+              <a:t>每个付费项目都沉淀配对数据</a:t>
+            </a:r>
+            <a:r>
+              <a:rPr lang="zh-CN" altLang="en-US" sz="1500" b="1">
+                <a:solidFill>
+                  <a:srgbClr val="08A6F6"/>
+                </a:solidFill>
+                <a:latin typeface="微软雅黑"/>
+                <a:ea typeface="微软雅黑"/>
+                <a:cs typeface="微软雅黑"/>
+              </a:rPr>
+              <a:t>  →  </a:t>
+            </a:r>
+            <a:r>
+              <a:rPr lang="zh-CN" altLang="en-US" sz="1500" b="1">
+                <a:solidFill>
+                  <a:srgbClr val="FFFFFF"/>
+                </a:solidFill>
+                <a:latin typeface="微软雅黑"/>
+                <a:ea typeface="微软雅黑"/>
+                <a:cs typeface="微软雅黑"/>
+              </a:rPr>
+              <a:t>模型越用越准</a:t>
+            </a:r>
+            <a:r>
+              <a:rPr lang="zh-CN" altLang="en-US" sz="1500" b="1">
+                <a:solidFill>
+                  <a:srgbClr val="08A6F6"/>
+                </a:solidFill>
+                <a:latin typeface="微软雅黑"/>
+                <a:ea typeface="微软雅黑"/>
+                <a:cs typeface="微软雅黑"/>
+              </a:rPr>
+              <a:t>  →  </a:t>
+            </a:r>
+            <a:r>
+              <a:rPr lang="zh-CN" altLang="en-US" sz="1500" b="1">
+                <a:solidFill>
+                  <a:srgbClr val="FFFFFF"/>
+                </a:solidFill>
+                <a:latin typeface="微软雅黑"/>
+                <a:ea typeface="微软雅黑"/>
+                <a:cs typeface="微软雅黑"/>
+              </a:rPr>
+              <a:t>交付越做越省</a:t>
             </a:r>
           </a:p>
         </p:txBody>
@@ -2784,7 +2602,7 @@
                 <a:ea typeface="微软雅黑"/>
                 <a:cs typeface="微软雅黑"/>
               </a:rPr>
-              <a:t>八成用于拿到第 12 个月的证据，两成留作 Plan B 准备金；融资期内不计收入（保守口径）</a:t>
+              <a:t>八成用于拿到第 12 个月的关键证据，两成作为运营储备；融资期内不计收入（保守口径）</a:t>
             </a:r>
             <a:r>
               <a:rPr lang="zh-CN" altLang="en-US" sz="1275">
@@ -2913,7 +2731,7 @@
                 <a:ea typeface="微软雅黑"/>
                 <a:cs typeface="微软雅黑"/>
               </a:rPr>
-              <a:t>资金用途（初稿，金额待团队确认）</a:t>
+              <a:t>资金用途</a:t>
             </a:r>
             <a:endParaRPr sz="1275" b="1">
               <a:solidFill>
@@ -3246,7 +3064,7 @@
                 <a:ea typeface="微软雅黑"/>
                 <a:cs typeface="微软雅黑"/>
               </a:rPr>
-              <a:t>Plan B 准备金</a:t>
+              <a:t>运营储备</a:t>
             </a:r>
             <a:r>
               <a:rPr sz="1050">
@@ -3753,7 +3571,7 @@
                 <a:ea typeface="微软雅黑"/>
                 <a:cs typeface="微软雅黑"/>
               </a:rPr>
-              <a:t>团队 14 → 约 26 人；设备约 650 万、实验室约 500 m²；算力按王博测算</a:t>
+              <a:t>团队 14 → 约 26 人；设备约 650 万、实验室约 500 m²；算力与数据平台</a:t>
             </a:r>
             <a:r>
               <a:rPr lang="zh-CN" altLang="en-US" sz="1100">
@@ -4240,7 +4058,7 @@
                 <a:ea typeface="微软雅黑"/>
                 <a:cs typeface="微软雅黑"/>
               </a:rPr>
-              <a:t>Plan B 准备金｜约 990 万</a:t>
+              <a:t>运营储备｜约 990 万</a:t>
             </a:r>
             <a:r>
               <a:rPr sz="1425" b="1">
@@ -4321,7 +4139,7 @@
                 <a:ea typeface="微软雅黑"/>
                 <a:cs typeface="微软雅黑"/>
               </a:rPr>
-              <a:t>独立账户；闸门未过或融资受阻时，经董事会批准才能动用</a:t>
+              <a:t>延长跑道，应对入组或融资节奏变化</a:t>
             </a:r>
             <a:r>
               <a:rPr lang="zh-CN" altLang="en-US" sz="1100">
@@ -4445,295 +4263,6 @@
                 <a:srgbClr val="99BDED">
                   <a:alpha val="100000"/>
                 </a:srgbClr>
-              </a:solidFill>
-              <a:latin typeface="微软雅黑"/>
-              <a:ea typeface="微软雅黑"/>
-              <a:cs typeface="微软雅黑"/>
-            </a:endParaRPr>
-          </a:p>
-        </p:txBody>
-      </p:sp>
-      <p:sp>
-        <p:nvSpPr>
-          <p:cNvPr id="228" name="文本框 190"/>
-          <p:cNvSpPr>
-            <a:spLocks noGrp="1"/>
-          </p:cNvSpPr>
-          <p:nvPr/>
-        </p:nvSpPr>
-        <p:spPr>
-          <a:xfrm>
-            <a:off x="676184" y="5649115"/>
-            <a:ext cx="771616" cy="286277"/>
-          </a:xfrm>
-          <a:prstGeom prst="rect">
-            <a:avLst/>
-          </a:prstGeom>
-        </p:spPr>
-        <p:txBody>
-          <a:bodyPr wrap="none" lIns="0" tIns="0" rIns="0" bIns="0"/>
-          <a:lstStyle/>
-          <a:p>
-            <a:pPr>
-              <a:lnSpc>
-                <a:spcPct val="100000"/>
-              </a:lnSpc>
-              <a:buNone/>
-            </a:pPr>
-            <a:r>
-              <a:rPr sz="1400" b="1">
-                <a:solidFill>
-                  <a:srgbClr val="99BDED"/>
-                </a:solidFill>
-                <a:latin typeface="微软雅黑"/>
-                <a:ea typeface="微软雅黑"/>
-                <a:cs typeface="微软雅黑"/>
-              </a:rPr>
-              <a:t>收缩顺序：</a:t>
-            </a:r>
-            <a:endParaRPr sz="1400" b="1">
-              <a:solidFill>
-                <a:srgbClr val="99BDED"/>
-              </a:solidFill>
-              <a:latin typeface="微软雅黑"/>
-              <a:ea typeface="微软雅黑"/>
-              <a:cs typeface="微软雅黑"/>
-            </a:endParaRPr>
-          </a:p>
-        </p:txBody>
-      </p:sp>
-      <p:sp>
-        <p:nvSpPr>
-          <p:cNvPr id="229" name="文本框 191"/>
-          <p:cNvSpPr>
-            <a:spLocks noGrp="1"/>
-          </p:cNvSpPr>
-          <p:nvPr/>
-        </p:nvSpPr>
-        <p:spPr>
-          <a:xfrm>
-            <a:off x="1562100" y="5649115"/>
-            <a:ext cx="1457325" cy="200025"/>
-          </a:xfrm>
-          <a:prstGeom prst="rect">
-            <a:avLst/>
-          </a:prstGeom>
-        </p:spPr>
-        <p:txBody>
-          <a:bodyPr wrap="none" lIns="0" tIns="0" rIns="0" bIns="0"/>
-          <a:lstStyle/>
-          <a:p>
-            <a:pPr>
-              <a:lnSpc>
-                <a:spcPct val="100000"/>
-              </a:lnSpc>
-              <a:buNone/>
-            </a:pPr>
-            <a:r>
-              <a:rPr sz="1400" b="1">
-                <a:solidFill>
-                  <a:srgbClr val="FFFFFF"/>
-                </a:solidFill>
-                <a:latin typeface="微软雅黑"/>
-                <a:ea typeface="微软雅黑"/>
-                <a:cs typeface="微软雅黑"/>
-              </a:rPr>
-              <a:t>先砍 C 商业与运营</a:t>
-            </a:r>
-            <a:endParaRPr sz="1400" b="1">
-              <a:solidFill>
-                <a:srgbClr val="FFFFFF"/>
-              </a:solidFill>
-              <a:latin typeface="微软雅黑"/>
-              <a:ea typeface="微软雅黑"/>
-              <a:cs typeface="微软雅黑"/>
-            </a:endParaRPr>
-          </a:p>
-        </p:txBody>
-      </p:sp>
-      <p:pic>
-        <p:nvPicPr>
-          <p:cNvPr id="271" name="图片 192"/>
-          <p:cNvPicPr>
-            <a:picLocks noChangeAspect="1"/>
-          </p:cNvPicPr>
-          <p:nvPr/>
-        </p:nvPicPr>
-        <p:blipFill>
-          <a:blip r:embed="rId1">
-            <a:extLst>
-              <a:ext uri="{96DAC541-7B7A-43D3-8B79-37D633B846F1}">
-                <asvg:svgBlip xmlns:asvg="http://schemas.microsoft.com/office/drawing/2016/SVG/main" r:embed="rId2"/>
-              </a:ext>
-            </a:extLst>
-          </a:blip>
-          <a:stretch>
-            <a:fillRect/>
-          </a:stretch>
-        </p:blipFill>
-        <p:spPr>
-          <a:xfrm>
-            <a:off x="3133725" y="5677690"/>
-            <a:ext cx="209550" cy="152400"/>
-          </a:xfrm>
-          <a:prstGeom prst="rect">
-            <a:avLst/>
-          </a:prstGeom>
-        </p:spPr>
-      </p:pic>
-      <p:sp>
-        <p:nvSpPr>
-          <p:cNvPr id="231" name="文本框 193"/>
-          <p:cNvSpPr>
-            <a:spLocks noGrp="1"/>
-          </p:cNvSpPr>
-          <p:nvPr/>
-        </p:nvSpPr>
-        <p:spPr>
-          <a:xfrm>
-            <a:off x="3457575" y="5649115"/>
-            <a:ext cx="1619250" cy="200025"/>
-          </a:xfrm>
-          <a:prstGeom prst="rect">
-            <a:avLst/>
-          </a:prstGeom>
-        </p:spPr>
-        <p:txBody>
-          <a:bodyPr wrap="none" lIns="0" tIns="0" rIns="0" bIns="0"/>
-          <a:lstStyle/>
-          <a:p>
-            <a:pPr>
-              <a:lnSpc>
-                <a:spcPct val="100000"/>
-              </a:lnSpc>
-              <a:buNone/>
-            </a:pPr>
-            <a:r>
-              <a:rPr sz="1400" b="1">
-                <a:solidFill>
-                  <a:srgbClr val="FFFFFF"/>
-                </a:solidFill>
-                <a:latin typeface="微软雅黑"/>
-                <a:ea typeface="微软雅黑"/>
-                <a:cs typeface="微软雅黑"/>
-              </a:rPr>
-              <a:t>再砍 B 能力建设</a:t>
-            </a:r>
-            <a:endParaRPr sz="1400" b="1">
-              <a:solidFill>
-                <a:srgbClr val="FFFFFF"/>
-              </a:solidFill>
-              <a:latin typeface="微软雅黑"/>
-              <a:ea typeface="微软雅黑"/>
-              <a:cs typeface="微软雅黑"/>
-            </a:endParaRPr>
-          </a:p>
-        </p:txBody>
-      </p:sp>
-      <p:pic>
-        <p:nvPicPr>
-          <p:cNvPr id="273" name="图片 194"/>
-          <p:cNvPicPr>
-            <a:picLocks noChangeAspect="1"/>
-          </p:cNvPicPr>
-          <p:nvPr/>
-        </p:nvPicPr>
-        <p:blipFill>
-          <a:blip r:embed="rId1">
-            <a:extLst>
-              <a:ext uri="{96DAC541-7B7A-43D3-8B79-37D633B846F1}">
-                <asvg:svgBlip xmlns:asvg="http://schemas.microsoft.com/office/drawing/2016/SVG/main" r:embed="rId2"/>
-              </a:ext>
-            </a:extLst>
-          </a:blip>
-          <a:stretch>
-            <a:fillRect/>
-          </a:stretch>
-        </p:blipFill>
-        <p:spPr>
-          <a:xfrm>
-            <a:off x="5191125" y="5677690"/>
-            <a:ext cx="209550" cy="152400"/>
-          </a:xfrm>
-          <a:prstGeom prst="rect">
-            <a:avLst/>
-          </a:prstGeom>
-        </p:spPr>
-      </p:pic>
-      <p:sp>
-        <p:nvSpPr>
-          <p:cNvPr id="233" name="文本框 195"/>
-          <p:cNvSpPr>
-            <a:spLocks noGrp="1"/>
-          </p:cNvSpPr>
-          <p:nvPr/>
-        </p:nvSpPr>
-        <p:spPr>
-          <a:xfrm>
-            <a:off x="5514975" y="5649115"/>
-            <a:ext cx="1943100" cy="200025"/>
-          </a:xfrm>
-          <a:prstGeom prst="rect">
-            <a:avLst/>
-          </a:prstGeom>
-        </p:spPr>
-        <p:txBody>
-          <a:bodyPr wrap="none" lIns="0" tIns="0" rIns="0" bIns="0"/>
-          <a:lstStyle/>
-          <a:p>
-            <a:pPr>
-              <a:lnSpc>
-                <a:spcPct val="100000"/>
-              </a:lnSpc>
-              <a:buNone/>
-            </a:pPr>
-            <a:r>
-              <a:rPr sz="1400" b="1">
-                <a:solidFill>
-                  <a:srgbClr val="08A6F6"/>
-                </a:solidFill>
-                <a:latin typeface="微软雅黑"/>
-                <a:ea typeface="微软雅黑"/>
-                <a:cs typeface="微软雅黑"/>
-              </a:rPr>
-              <a:t>最后才动 A 核心数据</a:t>
-            </a:r>
-            <a:r>
-              <a:rPr sz="1400" b="1">
-                <a:solidFill>
-                  <a:srgbClr val="08A6F6"/>
-                </a:solidFill>
-                <a:latin typeface="微软雅黑"/>
-                <a:ea typeface="微软雅黑"/>
-                <a:cs typeface="Arial" panose="020B0604020202020204" pitchFamily="34" charset="0"/>
-              </a:rPr>
-              <a:t/>
-            </a:r>
-            <a:r>
-              <a:rPr sz="1400" b="1">
-                <a:solidFill>
-                  <a:srgbClr val="08A6F6"/>
-                </a:solidFill>
-                <a:latin typeface="微软雅黑"/>
-                <a:ea typeface="微软雅黑"/>
-                <a:cs typeface="微软雅黑"/>
-              </a:rPr>
-              <a:t/>
-            </a:r>
-            <a:r>
-              <a:rPr lang="zh-CN" altLang="en-US" sz="1400" b="1">
-                <a:solidFill>
-                  <a:srgbClr val="08A6F6"/>
-                </a:solidFill>
-                <a:latin typeface="微软雅黑"/>
-                <a:ea typeface="微软雅黑"/>
-                <a:cs typeface="微软雅黑"/>
-              </a:rPr>
-              <a:t/>
-            </a:r>
-            <a:endParaRPr sz="1400" b="1">
-              <a:solidFill>
-                <a:srgbClr val="08A6F6"/>
               </a:solidFill>
               <a:latin typeface="微软雅黑"/>
               <a:ea typeface="微软雅黑"/>
@@ -4798,15 +4327,15 @@
         </p:nvSpPr>
         <p:spPr>
           <a:xfrm>
-            <a:off x="685800" y="6305550"/>
-            <a:ext cx="5495925" cy="171450"/>
-          </a:xfrm>
-          <a:prstGeom prst="rect">
-            <a:avLst/>
-          </a:prstGeom>
-        </p:spPr>
-        <p:txBody>
-          <a:bodyPr wrap="none" lIns="0" tIns="0" rIns="0" bIns="0"/>
+            <a:off x="685800" y="5532120"/>
+            <a:ext cx="10789920" cy="365760"/>
+          </a:xfrm>
+          <a:prstGeom prst="rect">
+            <a:avLst/>
+          </a:prstGeom>
+        </p:spPr>
+        <p:txBody>
+          <a:bodyPr anchor="ctr" wrap="none" lIns="0" tIns="0" rIns="0" bIns="0"/>
           <a:lstStyle/>
           <a:p>
             <a:pPr>
@@ -4816,9 +4345,9 @@
               <a:buNone/>
             </a:pPr>
             <a:r>
-              <a:rPr sz="1100" b="1">
-                <a:solidFill>
-                  <a:srgbClr val="99BDED"/>
+              <a:rPr sz="1600" b="1">
+                <a:solidFill>
+                  <a:srgbClr val="FFFFFF"/>
                 </a:solidFill>
                 <a:latin typeface="微软雅黑"/>
                 <a:ea typeface="微软雅黑"/>
@@ -4827,9 +4356,9 @@
               <a:t>钱先投给决定第 12 个月证据的地方：配对队列、深度读出、双轨迹校准首个结果。</a:t>
             </a:r>
             <a:r>
-              <a:rPr lang="zh-CN" altLang="en-US" sz="1100" b="1">
-                <a:solidFill>
-                  <a:srgbClr val="99BDED"/>
+              <a:rPr lang="zh-CN" altLang="en-US" sz="1600" b="1">
+                <a:solidFill>
+                  <a:srgbClr val="FFFFFF"/>
                 </a:solidFill>
                 <a:latin typeface="微软雅黑"/>
                 <a:ea typeface="微软雅黑"/>
@@ -4838,9 +4367,9 @@
               <a:t/>
             </a:r>
             <a:r>
-              <a:rPr sz="1100" b="1">
-                <a:solidFill>
-                  <a:srgbClr val="99BDED"/>
+              <a:rPr sz="1600" b="1">
+                <a:solidFill>
+                  <a:srgbClr val="FFFFFF"/>
                 </a:solidFill>
                 <a:latin typeface="微软雅黑"/>
                 <a:ea typeface="微软雅黑"/>
@@ -4849,9 +4378,9 @@
               <a:t/>
             </a:r>
             <a:r>
-              <a:rPr lang="zh-CN" altLang="en-US" sz="1100" b="1">
-                <a:solidFill>
-                  <a:srgbClr val="99BDED"/>
+              <a:rPr lang="zh-CN" altLang="en-US" sz="1600" b="1">
+                <a:solidFill>
+                  <a:srgbClr val="FFFFFF"/>
                 </a:solidFill>
                 <a:latin typeface="微软雅黑"/>
                 <a:ea typeface="微软雅黑"/>
@@ -4860,9 +4389,9 @@
               <a:t/>
             </a:r>
             <a:r>
-              <a:rPr sz="1100" b="1">
-                <a:solidFill>
-                  <a:srgbClr val="99BDED"/>
+              <a:rPr sz="1600" b="1">
+                <a:solidFill>
+                  <a:srgbClr val="FFFFFF"/>
                 </a:solidFill>
                 <a:latin typeface="微软雅黑"/>
                 <a:ea typeface="微软雅黑"/>
@@ -4871,9 +4400,9 @@
               <a:t/>
             </a:r>
             <a:r>
-              <a:rPr lang="zh-CN" altLang="en-US" sz="1100" b="1">
-                <a:solidFill>
-                  <a:srgbClr val="99BDED"/>
+              <a:rPr lang="zh-CN" altLang="en-US" sz="1600" b="1">
+                <a:solidFill>
+                  <a:srgbClr val="FFFFFF"/>
                 </a:solidFill>
                 <a:latin typeface="微软雅黑"/>
                 <a:ea typeface="微软雅黑"/>
@@ -4882,9 +4411,9 @@
               <a:t/>
             </a:r>
             <a:r>
-              <a:rPr sz="1100" b="1">
-                <a:solidFill>
-                  <a:srgbClr val="99BDED"/>
+              <a:rPr sz="1600" b="1">
+                <a:solidFill>
+                  <a:srgbClr val="FFFFFF"/>
                 </a:solidFill>
                 <a:latin typeface="微软雅黑"/>
                 <a:ea typeface="微软雅黑"/>
@@ -4893,9 +4422,9 @@
               <a:t/>
             </a:r>
             <a:r>
-              <a:rPr lang="zh-CN" altLang="en-US" sz="1100" b="1">
-                <a:solidFill>
-                  <a:srgbClr val="99BDED"/>
+              <a:rPr lang="zh-CN" altLang="en-US" sz="1600" b="1">
+                <a:solidFill>
+                  <a:srgbClr val="FFFFFF"/>
                 </a:solidFill>
                 <a:latin typeface="微软雅黑"/>
                 <a:ea typeface="微软雅黑"/>
@@ -4903,9 +4432,9 @@
               </a:rPr>
               <a:t/>
             </a:r>
-            <a:endParaRPr sz="1100" b="1">
+            <a:endParaRPr sz="1600" b="1">
               <a:solidFill>
-                <a:srgbClr val="99BDED"/>
+                <a:srgbClr val="FFFFFF"/>
               </a:solidFill>
               <a:latin typeface="微软雅黑"/>
               <a:ea typeface="微软雅黑"/>
@@ -5140,7 +4669,7 @@
                 <a:ea typeface="微软雅黑"/>
                 <a:cs typeface="微软雅黑"/>
               </a:rPr>
-              <a:t>Source: 卓悦博士《AIVC 第一年执行计划》；Tahoe Therapeutics 公开融资信息（2025）；病例数与 AUROC 目标待团队确认</a:t>
+              <a:t>Source: Vitonaut 第一年执行计划；Tahoe Therapeutics 公开融资信息（2025）</a:t>
             </a:r>
             <a:endParaRPr sz="1050">
               <a:solidFill>
@@ -5744,7 +5273,7 @@
                 <a:ea typeface="微软雅黑"/>
                 <a:cs typeface="微软雅黑"/>
               </a:rPr>
-              <a:t>回顾性 AUROC 首评 · 药企条款谈判</a:t>
+              <a:t>回顾性预测准确度首评 · 药企合作洽谈</a:t>
             </a:r>
           </a:p>
         </p:txBody>
@@ -5901,7 +5430,7 @@
                 <a:ea typeface="微软雅黑"/>
                 <a:cs typeface="微软雅黑"/>
               </a:rPr>
-              <a:t>约 100 例配对 · AUROC 验证 · 双轨迹首个结果 · 首个付费项目</a:t>
+              <a:t>约 100 例配对 · 预测准确度验证 · 双轨迹首个结果 · 首个付费项目</a:t>
             </a:r>
           </a:p>
         </p:txBody>
@@ -6221,7 +5750,7 @@
                 <a:ea typeface="微软雅黑"/>
                 <a:cs typeface="微软雅黑"/>
               </a:rPr>
-              <a:t>下一轮融资 → 战略并购（药企 / CRO / AI 制药平台）→ IPO</a:t>
+              <a:t>战略并购（药企 / CRO / AI 制药平台）或 IPO</a:t>
             </a:r>
           </a:p>
         </p:txBody>
@@ -6271,7 +5800,7 @@
                 <a:ea typeface="微软雅黑"/>
                 <a:cs typeface="微软雅黑"/>
               </a:rPr>
-              <a:t>参照案例</a:t>
+              <a:t>赛道参照</a:t>
             </a:r>
           </a:p>
           <a:p>
@@ -6483,7 +6012,7 @@
                 <a:ea typeface="微软雅黑"/>
                 <a:cs typeface="微软雅黑"/>
               </a:rPr>
-              <a:t>试错走到尽头</a:t>
+              <a:t>研发试错代价已不可承受</a:t>
             </a:r>
           </a:p>
         </p:txBody>

</xml_diff>